<commit_message>
Rebuild the slide as a fixed ring image with editable text
The native pie-and-triangle wedges made clumsy arrowheads, so the cycle is
now the matplotlib ring, whose arrow tips taper into their own segment.
pdca_diagram.py gains a "gelang" mode that renders the ring with no text at
an exact +/-0.90 unit extent, and the slide places it as a square of side S
so every label position follows from one scale factor.

Only the words remain as shapes: phase labels, the hub text, the four item
blocks, title and footer are each their own text box.

Co-Authored-By: Claude Opus 5 <noreply@anthropic.com>
Claude-Session: https://claude.ai/code/session_01WfmAN69xzS4NUgAA8zD4ah
</commit_message>
<xml_diff>
--- a/output/PDCA_VAS_Kitaran_Slaid.pptx
+++ b/output/PDCA_VAS_Kitaran_Slaid.pptx
@@ -914,228 +914,40 @@
           </a:p>
         </p:txBody>
       </p:sp>
-      <p:sp>
-        <p:nvSpPr>
-          <p:cNvPr id="3" name="Shape 1"/>
+      <p:pic>
+        <p:nvPicPr>
+          <p:cNvPr id="3" name="Image 0" descr="/home/user/Reject-VAS/output/pdca_gelang.png">    </p:cNvPr>
+          <p:cNvPicPr>
+            <a:picLocks noChangeAspect="1"/>
+          </p:cNvPicPr>
+          <p:nvPr/>
+        </p:nvPicPr>
+        <p:blipFill>
+          <a:blip r:embed="rId1"/>
+          <a:stretch>
+            <a:fillRect/>
+          </a:stretch>
+        </p:blipFill>
+        <p:spPr>
+          <a:xfrm>
+            <a:off x="3718865" y="1280160"/>
+            <a:ext cx="4754880" cy="4754880"/>
+          </a:xfrm>
+          <a:prstGeom prst="rect">
+            <a:avLst/>
+          </a:prstGeom>
+        </p:spPr>
+      </p:pic>
+      <p:sp>
+        <p:nvSpPr>
+          <p:cNvPr id="4" name="Text 1"/>
           <p:cNvSpPr/>
           <p:nvPr/>
         </p:nvSpPr>
         <p:spPr>
           <a:xfrm>
-            <a:off x="3993185" y="1554480"/>
-            <a:ext cx="4206240" cy="4206240"/>
-          </a:xfrm>
-          <a:prstGeom prst="pie">
-            <a:avLst>
-              <a:gd name="adj1" fmla="val 16800000"/>
-              <a:gd name="adj2" fmla="val 21000000"/>
-            </a:avLst>
-          </a:prstGeom>
-          <a:solidFill>
-            <a:srgbClr val="028090"/>
-          </a:solidFill>
-          <a:ln/>
-        </p:spPr>
-      </p:sp>
-      <p:sp>
-        <p:nvSpPr>
-          <p:cNvPr id="4" name="Shape 2"/>
-          <p:cNvSpPr/>
-          <p:nvPr/>
-        </p:nvSpPr>
-        <p:spPr>
-          <a:xfrm>
-            <a:off x="3993185" y="1554480"/>
-            <a:ext cx="4206240" cy="4206240"/>
-          </a:xfrm>
-          <a:prstGeom prst="pie">
-            <a:avLst>
-              <a:gd name="adj1" fmla="val 600000"/>
-              <a:gd name="adj2" fmla="val 4800000"/>
-            </a:avLst>
-          </a:prstGeom>
-          <a:solidFill>
-            <a:srgbClr val="00A896"/>
-          </a:solidFill>
-          <a:ln/>
-        </p:spPr>
-      </p:sp>
-      <p:sp>
-        <p:nvSpPr>
-          <p:cNvPr id="5" name="Shape 3"/>
-          <p:cNvSpPr/>
-          <p:nvPr/>
-        </p:nvSpPr>
-        <p:spPr>
-          <a:xfrm>
-            <a:off x="3993185" y="1554480"/>
-            <a:ext cx="4206240" cy="4206240"/>
-          </a:xfrm>
-          <a:prstGeom prst="pie">
-            <a:avLst>
-              <a:gd name="adj1" fmla="val 6000000"/>
-              <a:gd name="adj2" fmla="val 10200000"/>
-            </a:avLst>
-          </a:prstGeom>
-          <a:solidFill>
-            <a:srgbClr val="E08A3C"/>
-          </a:solidFill>
-          <a:ln/>
-        </p:spPr>
-      </p:sp>
-      <p:sp>
-        <p:nvSpPr>
-          <p:cNvPr id="6" name="Shape 4"/>
-          <p:cNvSpPr/>
-          <p:nvPr/>
-        </p:nvSpPr>
-        <p:spPr>
-          <a:xfrm>
-            <a:off x="3993185" y="1554480"/>
-            <a:ext cx="4206240" cy="4206240"/>
-          </a:xfrm>
-          <a:prstGeom prst="pie">
-            <a:avLst>
-              <a:gd name="adj1" fmla="val 11400000"/>
-              <a:gd name="adj2" fmla="val 15600000"/>
-            </a:avLst>
-          </a:prstGeom>
-          <a:solidFill>
-            <a:srgbClr val="083F49"/>
-          </a:solidFill>
-          <a:ln/>
-        </p:spPr>
-      </p:sp>
-      <p:sp>
-        <p:nvSpPr>
-          <p:cNvPr id="7" name="Shape 5"/>
-          <p:cNvSpPr/>
-          <p:nvPr/>
-        </p:nvSpPr>
-        <p:spPr>
-          <a:xfrm>
-            <a:off x="5090465" y="2651760"/>
-            <a:ext cx="2011680" cy="2011680"/>
-          </a:xfrm>
-          <a:prstGeom prst="ellipse">
-            <a:avLst/>
-          </a:prstGeom>
-          <a:solidFill>
-            <a:srgbClr val="FFFFFF"/>
-          </a:solidFill>
-          <a:ln/>
-        </p:spPr>
-      </p:sp>
-      <p:sp>
-        <p:nvSpPr>
-          <p:cNvPr id="8" name="Shape 6"/>
-          <p:cNvSpPr/>
-          <p:nvPr/>
-        </p:nvSpPr>
-        <p:spPr>
-          <a:xfrm>
-            <a:off x="5227625" y="2788920"/>
-            <a:ext cx="1737360" cy="1737360"/>
-          </a:xfrm>
-          <a:prstGeom prst="ellipse">
-            <a:avLst/>
-          </a:prstGeom>
-          <a:solidFill>
-            <a:srgbClr val="083F49"/>
-          </a:solidFill>
-          <a:ln/>
-        </p:spPr>
-      </p:sp>
-      <p:sp>
-        <p:nvSpPr>
-          <p:cNvPr id="9" name="Shape 7"/>
-          <p:cNvSpPr/>
-          <p:nvPr/>
-        </p:nvSpPr>
-        <p:spPr>
-          <a:xfrm rot="10560000">
-            <a:off x="7253806" y="3274845"/>
-            <a:ext cx="786384" cy="548640"/>
-          </a:xfrm>
-          <a:prstGeom prst="triangle">
-            <a:avLst/>
-          </a:prstGeom>
-          <a:solidFill>
-            <a:srgbClr val="028090"/>
-          </a:solidFill>
-          <a:ln/>
-        </p:spPr>
-      </p:sp>
-      <p:sp>
-        <p:nvSpPr>
-          <p:cNvPr id="10" name="Shape 8"/>
-          <p:cNvSpPr/>
-          <p:nvPr/>
-        </p:nvSpPr>
-        <p:spPr>
-          <a:xfrm rot="15960000">
-            <a:off x="5811548" y="4933973"/>
-            <a:ext cx="786384" cy="548640"/>
-          </a:xfrm>
-          <a:prstGeom prst="triangle">
-            <a:avLst/>
-          </a:prstGeom>
-          <a:solidFill>
-            <a:srgbClr val="00A896"/>
-          </a:solidFill>
-          <a:ln/>
-        </p:spPr>
-      </p:sp>
-      <p:sp>
-        <p:nvSpPr>
-          <p:cNvPr id="11" name="Shape 9"/>
-          <p:cNvSpPr/>
-          <p:nvPr/>
-        </p:nvSpPr>
-        <p:spPr>
-          <a:xfrm rot="21360000">
-            <a:off x="4152419" y="3491715"/>
-            <a:ext cx="786384" cy="548640"/>
-          </a:xfrm>
-          <a:prstGeom prst="triangle">
-            <a:avLst/>
-          </a:prstGeom>
-          <a:solidFill>
-            <a:srgbClr val="E08A3C"/>
-          </a:solidFill>
-          <a:ln/>
-        </p:spPr>
-      </p:sp>
-      <p:sp>
-        <p:nvSpPr>
-          <p:cNvPr id="12" name="Shape 10"/>
-          <p:cNvSpPr/>
-          <p:nvPr/>
-        </p:nvSpPr>
-        <p:spPr>
-          <a:xfrm rot="5160000">
-            <a:off x="5594678" y="1832587"/>
-            <a:ext cx="786384" cy="548640"/>
-          </a:xfrm>
-          <a:prstGeom prst="triangle">
-            <a:avLst/>
-          </a:prstGeom>
-          <a:solidFill>
-            <a:srgbClr val="083F49"/>
-          </a:solidFill>
-          <a:ln/>
-        </p:spPr>
-      </p:sp>
-      <p:sp>
-        <p:nvSpPr>
-          <p:cNvPr id="13" name="Text 11"/>
-          <p:cNvSpPr/>
-          <p:nvPr/>
-        </p:nvSpPr>
-        <p:spPr>
-          <a:xfrm>
-            <a:off x="6542017" y="2169472"/>
-            <a:ext cx="1371600" cy="420624"/>
+            <a:off x="6554489" y="2184432"/>
+            <a:ext cx="1463040" cy="329184"/>
           </a:xfrm>
           <a:prstGeom prst="rect">
             <a:avLst/>
@@ -1151,7 +963,7 @@
               <a:buNone/>
             </a:pPr>
             <a:r>
-              <a:rPr lang="en-US" sz="2000" b="1" dirty="0">
+              <a:rPr lang="en-US" sz="1800" b="1" dirty="0">
                 <a:solidFill>
                   <a:srgbClr val="FFFFFF"/>
                 </a:solidFill>
@@ -1161,20 +973,20 @@
               </a:rPr>
               <a:t>PLAN</a:t>
             </a:r>
-            <a:endParaRPr lang="en-US" sz="2000" dirty="0"/>
-          </a:p>
-        </p:txBody>
-      </p:sp>
-      <p:sp>
-        <p:nvSpPr>
-          <p:cNvPr id="14" name="Text 12"/>
+            <a:endParaRPr lang="en-US" sz="1800" dirty="0"/>
+          </a:p>
+        </p:txBody>
+      </p:sp>
+      <p:sp>
+        <p:nvSpPr>
+          <p:cNvPr id="5" name="Text 2"/>
           <p:cNvSpPr/>
           <p:nvPr/>
         </p:nvSpPr>
         <p:spPr>
           <a:xfrm>
-            <a:off x="6542017" y="2599240"/>
-            <a:ext cx="1371600" cy="310896"/>
+            <a:off x="6554489" y="2531904"/>
+            <a:ext cx="1463040" cy="256032"/>
           </a:xfrm>
           <a:prstGeom prst="rect">
             <a:avLst/>
@@ -1190,7 +1002,7 @@
               <a:buNone/>
             </a:pPr>
             <a:r>
-              <a:rPr lang="en-US" sz="1200" dirty="0">
+              <a:rPr lang="en-US" sz="1100" dirty="0">
                 <a:solidFill>
                   <a:srgbClr val="FFFFFF"/>
                 </a:solidFill>
@@ -1200,20 +1012,20 @@
               </a:rPr>
               <a:t>Rancang</a:t>
             </a:r>
-            <a:endParaRPr lang="en-US" sz="1200" dirty="0"/>
-          </a:p>
-        </p:txBody>
-      </p:sp>
-      <p:sp>
-        <p:nvSpPr>
-          <p:cNvPr id="15" name="Text 13"/>
+            <a:endParaRPr lang="en-US" sz="1100" dirty="0"/>
+          </a:p>
+        </p:txBody>
+      </p:sp>
+      <p:sp>
+        <p:nvSpPr>
+          <p:cNvPr id="6" name="Text 3"/>
           <p:cNvSpPr/>
           <p:nvPr/>
         </p:nvSpPr>
         <p:spPr>
           <a:xfrm>
-            <a:off x="6542017" y="4432496"/>
-            <a:ext cx="1371600" cy="420624"/>
+            <a:off x="6554489" y="4563840"/>
+            <a:ext cx="1463040" cy="329184"/>
           </a:xfrm>
           <a:prstGeom prst="rect">
             <a:avLst/>
@@ -1229,7 +1041,7 @@
               <a:buNone/>
             </a:pPr>
             <a:r>
-              <a:rPr lang="en-US" sz="2000" b="1" dirty="0">
+              <a:rPr lang="en-US" sz="1800" b="1" dirty="0">
                 <a:solidFill>
                   <a:srgbClr val="FFFFFF"/>
                 </a:solidFill>
@@ -1239,20 +1051,20 @@
               </a:rPr>
               <a:t>DO</a:t>
             </a:r>
-            <a:endParaRPr lang="en-US" sz="2000" dirty="0"/>
-          </a:p>
-        </p:txBody>
-      </p:sp>
-      <p:sp>
-        <p:nvSpPr>
-          <p:cNvPr id="16" name="Text 14"/>
+            <a:endParaRPr lang="en-US" sz="1800" dirty="0"/>
+          </a:p>
+        </p:txBody>
+      </p:sp>
+      <p:sp>
+        <p:nvSpPr>
+          <p:cNvPr id="7" name="Text 4"/>
           <p:cNvSpPr/>
           <p:nvPr/>
         </p:nvSpPr>
         <p:spPr>
           <a:xfrm>
-            <a:off x="6542017" y="4862264"/>
-            <a:ext cx="1371600" cy="310896"/>
+            <a:off x="6554489" y="4911312"/>
+            <a:ext cx="1463040" cy="256032"/>
           </a:xfrm>
           <a:prstGeom prst="rect">
             <a:avLst/>
@@ -1268,7 +1080,7 @@
               <a:buNone/>
             </a:pPr>
             <a:r>
-              <a:rPr lang="en-US" sz="1200" dirty="0">
+              <a:rPr lang="en-US" sz="1100" dirty="0">
                 <a:solidFill>
                   <a:srgbClr val="FFFFFF"/>
                 </a:solidFill>
@@ -1278,20 +1090,20 @@
               </a:rPr>
               <a:t>Laksana</a:t>
             </a:r>
-            <a:endParaRPr lang="en-US" sz="1200" dirty="0"/>
-          </a:p>
-        </p:txBody>
-      </p:sp>
-      <p:sp>
-        <p:nvSpPr>
-          <p:cNvPr id="17" name="Text 15"/>
+            <a:endParaRPr lang="en-US" sz="1100" dirty="0"/>
+          </a:p>
+        </p:txBody>
+      </p:sp>
+      <p:sp>
+        <p:nvSpPr>
+          <p:cNvPr id="8" name="Text 5"/>
           <p:cNvSpPr/>
           <p:nvPr/>
         </p:nvSpPr>
         <p:spPr>
           <a:xfrm>
-            <a:off x="4278993" y="4432496"/>
-            <a:ext cx="1371600" cy="420624"/>
+            <a:off x="4175080" y="4563840"/>
+            <a:ext cx="1463040" cy="329184"/>
           </a:xfrm>
           <a:prstGeom prst="rect">
             <a:avLst/>
@@ -1307,7 +1119,7 @@
               <a:buNone/>
             </a:pPr>
             <a:r>
-              <a:rPr lang="en-US" sz="2000" b="1" dirty="0">
+              <a:rPr lang="en-US" sz="1800" b="1" dirty="0">
                 <a:solidFill>
                   <a:srgbClr val="FFFFFF"/>
                 </a:solidFill>
@@ -1317,20 +1129,20 @@
               </a:rPr>
               <a:t>CHECK</a:t>
             </a:r>
-            <a:endParaRPr lang="en-US" sz="2000" dirty="0"/>
-          </a:p>
-        </p:txBody>
-      </p:sp>
-      <p:sp>
-        <p:nvSpPr>
-          <p:cNvPr id="18" name="Text 16"/>
+            <a:endParaRPr lang="en-US" sz="1800" dirty="0"/>
+          </a:p>
+        </p:txBody>
+      </p:sp>
+      <p:sp>
+        <p:nvSpPr>
+          <p:cNvPr id="9" name="Text 6"/>
           <p:cNvSpPr/>
           <p:nvPr/>
         </p:nvSpPr>
         <p:spPr>
           <a:xfrm>
-            <a:off x="4278993" y="4862264"/>
-            <a:ext cx="1371600" cy="310896"/>
+            <a:off x="4175080" y="4911312"/>
+            <a:ext cx="1463040" cy="256032"/>
           </a:xfrm>
           <a:prstGeom prst="rect">
             <a:avLst/>
@@ -1346,7 +1158,7 @@
               <a:buNone/>
             </a:pPr>
             <a:r>
-              <a:rPr lang="en-US" sz="1200" dirty="0">
+              <a:rPr lang="en-US" sz="1100" dirty="0">
                 <a:solidFill>
                   <a:srgbClr val="FFFFFF"/>
                 </a:solidFill>
@@ -1356,20 +1168,20 @@
               </a:rPr>
               <a:t>Semak</a:t>
             </a:r>
-            <a:endParaRPr lang="en-US" sz="1200" dirty="0"/>
-          </a:p>
-        </p:txBody>
-      </p:sp>
-      <p:sp>
-        <p:nvSpPr>
-          <p:cNvPr id="19" name="Text 17"/>
+            <a:endParaRPr lang="en-US" sz="1100" dirty="0"/>
+          </a:p>
+        </p:txBody>
+      </p:sp>
+      <p:sp>
+        <p:nvSpPr>
+          <p:cNvPr id="10" name="Text 7"/>
           <p:cNvSpPr/>
           <p:nvPr/>
         </p:nvSpPr>
         <p:spPr>
           <a:xfrm>
-            <a:off x="4278993" y="2169472"/>
-            <a:ext cx="1371600" cy="420624"/>
+            <a:off x="4175080" y="2184432"/>
+            <a:ext cx="1463040" cy="329184"/>
           </a:xfrm>
           <a:prstGeom prst="rect">
             <a:avLst/>
@@ -1385,7 +1197,7 @@
               <a:buNone/>
             </a:pPr>
             <a:r>
-              <a:rPr lang="en-US" sz="2000" b="1" dirty="0">
+              <a:rPr lang="en-US" sz="1800" b="1" dirty="0">
                 <a:solidFill>
                   <a:srgbClr val="FFFFFF"/>
                 </a:solidFill>
@@ -1395,20 +1207,20 @@
               </a:rPr>
               <a:t>ACT</a:t>
             </a:r>
-            <a:endParaRPr lang="en-US" sz="2000" dirty="0"/>
-          </a:p>
-        </p:txBody>
-      </p:sp>
-      <p:sp>
-        <p:nvSpPr>
-          <p:cNvPr id="20" name="Text 18"/>
+            <a:endParaRPr lang="en-US" sz="1800" dirty="0"/>
+          </a:p>
+        </p:txBody>
+      </p:sp>
+      <p:sp>
+        <p:nvSpPr>
+          <p:cNvPr id="11" name="Text 8"/>
           <p:cNvSpPr/>
           <p:nvPr/>
         </p:nvSpPr>
         <p:spPr>
           <a:xfrm>
-            <a:off x="4278993" y="2599240"/>
-            <a:ext cx="1371600" cy="310896"/>
+            <a:off x="4175080" y="2531904"/>
+            <a:ext cx="1463040" cy="256032"/>
           </a:xfrm>
           <a:prstGeom prst="rect">
             <a:avLst/>
@@ -1424,7 +1236,7 @@
               <a:buNone/>
             </a:pPr>
             <a:r>
-              <a:rPr lang="en-US" sz="1200" dirty="0">
+              <a:rPr lang="en-US" sz="1100" dirty="0">
                 <a:solidFill>
                   <a:srgbClr val="FFFFFF"/>
                 </a:solidFill>
@@ -1434,20 +1246,20 @@
               </a:rPr>
               <a:t>Tindak</a:t>
             </a:r>
-            <a:endParaRPr lang="en-US" sz="1200" dirty="0"/>
-          </a:p>
-        </p:txBody>
-      </p:sp>
-      <p:sp>
-        <p:nvSpPr>
-          <p:cNvPr id="21" name="Text 19"/>
+            <a:endParaRPr lang="en-US" sz="1100" dirty="0"/>
+          </a:p>
+        </p:txBody>
+      </p:sp>
+      <p:sp>
+        <p:nvSpPr>
+          <p:cNvPr id="12" name="Text 9"/>
           <p:cNvSpPr/>
           <p:nvPr/>
         </p:nvSpPr>
         <p:spPr>
           <a:xfrm>
-            <a:off x="5181905" y="2944368"/>
-            <a:ext cx="1828800" cy="274320"/>
+            <a:off x="5181905" y="2962656"/>
+            <a:ext cx="1828800" cy="237744"/>
           </a:xfrm>
           <a:prstGeom prst="rect">
             <a:avLst/>
@@ -1479,14 +1291,14 @@
       </p:sp>
       <p:sp>
         <p:nvSpPr>
-          <p:cNvPr id="22" name="Text 20"/>
+          <p:cNvPr id="13" name="Text 10"/>
           <p:cNvSpPr/>
           <p:nvPr/>
         </p:nvSpPr>
         <p:spPr>
           <a:xfrm>
-            <a:off x="5181905" y="3182112"/>
-            <a:ext cx="1828800" cy="603504"/>
+            <a:off x="5181905" y="3209544"/>
+            <a:ext cx="1828800" cy="585216"/>
           </a:xfrm>
           <a:prstGeom prst="rect">
             <a:avLst/>
@@ -1518,13 +1330,13 @@
       </p:sp>
       <p:sp>
         <p:nvSpPr>
-          <p:cNvPr id="23" name="Text 21"/>
+          <p:cNvPr id="14" name="Text 11"/>
           <p:cNvSpPr/>
           <p:nvPr/>
         </p:nvSpPr>
         <p:spPr>
           <a:xfrm>
-            <a:off x="5181905" y="3785616"/>
+            <a:off x="5181905" y="3803904"/>
             <a:ext cx="1828800" cy="329184"/>
           </a:xfrm>
           <a:prstGeom prst="rect">
@@ -1557,13 +1369,13 @@
       </p:sp>
       <p:sp>
         <p:nvSpPr>
-          <p:cNvPr id="24" name="Text 22"/>
+          <p:cNvPr id="15" name="Text 12"/>
           <p:cNvSpPr/>
           <p:nvPr/>
         </p:nvSpPr>
         <p:spPr>
           <a:xfrm>
-            <a:off x="5181905" y="4096512"/>
+            <a:off x="5181905" y="4151376"/>
             <a:ext cx="1828800" cy="256032"/>
           </a:xfrm>
           <a:prstGeom prst="rect">
@@ -1596,14 +1408,14 @@
       </p:sp>
       <p:sp>
         <p:nvSpPr>
-          <p:cNvPr id="25" name="Text 23"/>
+          <p:cNvPr id="16" name="Text 13"/>
           <p:cNvSpPr/>
           <p:nvPr/>
         </p:nvSpPr>
         <p:spPr>
           <a:xfrm>
-            <a:off x="8458200" y="960120"/>
-            <a:ext cx="3429000" cy="1371600"/>
+            <a:off x="8641080" y="960120"/>
+            <a:ext cx="3291840" cy="1371600"/>
           </a:xfrm>
           <a:prstGeom prst="rect">
             <a:avLst/>
@@ -1678,13 +1490,13 @@
       </p:sp>
       <p:sp>
         <p:nvSpPr>
-          <p:cNvPr id="26" name="Shape 24"/>
+          <p:cNvPr id="17" name="Shape 14"/>
           <p:cNvSpPr/>
           <p:nvPr/>
         </p:nvSpPr>
         <p:spPr>
           <a:xfrm>
-            <a:off x="8311896" y="1161288"/>
+            <a:off x="8494776" y="1161288"/>
             <a:ext cx="45720" cy="969264"/>
           </a:xfrm>
           <a:prstGeom prst="roundRect">
@@ -1700,14 +1512,14 @@
       </p:sp>
       <p:sp>
         <p:nvSpPr>
-          <p:cNvPr id="27" name="Text 25"/>
+          <p:cNvPr id="18" name="Text 15"/>
           <p:cNvSpPr/>
           <p:nvPr/>
         </p:nvSpPr>
         <p:spPr>
           <a:xfrm>
-            <a:off x="8458200" y="4434840"/>
-            <a:ext cx="3429000" cy="1371600"/>
+            <a:off x="8641080" y="4434840"/>
+            <a:ext cx="3291840" cy="1371600"/>
           </a:xfrm>
           <a:prstGeom prst="rect">
             <a:avLst/>
@@ -1782,13 +1594,13 @@
       </p:sp>
       <p:sp>
         <p:nvSpPr>
-          <p:cNvPr id="28" name="Shape 26"/>
+          <p:cNvPr id="19" name="Shape 16"/>
           <p:cNvSpPr/>
           <p:nvPr/>
         </p:nvSpPr>
         <p:spPr>
           <a:xfrm>
-            <a:off x="8311896" y="4636008"/>
+            <a:off x="8494776" y="4636008"/>
             <a:ext cx="45720" cy="969264"/>
           </a:xfrm>
           <a:prstGeom prst="roundRect">
@@ -1804,14 +1616,14 @@
       </p:sp>
       <p:sp>
         <p:nvSpPr>
-          <p:cNvPr id="29" name="Text 27"/>
+          <p:cNvPr id="20" name="Text 17"/>
           <p:cNvSpPr/>
           <p:nvPr/>
         </p:nvSpPr>
         <p:spPr>
           <a:xfrm>
-            <a:off x="320040" y="4434840"/>
-            <a:ext cx="3429000" cy="1371600"/>
+            <a:off x="274320" y="4434840"/>
+            <a:ext cx="3291840" cy="1371600"/>
           </a:xfrm>
           <a:prstGeom prst="rect">
             <a:avLst/>
@@ -1886,13 +1698,13 @@
       </p:sp>
       <p:sp>
         <p:nvSpPr>
-          <p:cNvPr id="30" name="Shape 28"/>
+          <p:cNvPr id="21" name="Shape 18"/>
           <p:cNvSpPr/>
           <p:nvPr/>
         </p:nvSpPr>
         <p:spPr>
           <a:xfrm>
-            <a:off x="3849624" y="4636008"/>
+            <a:off x="3666744" y="4636008"/>
             <a:ext cx="45720" cy="969264"/>
           </a:xfrm>
           <a:prstGeom prst="roundRect">
@@ -1908,14 +1720,14 @@
       </p:sp>
       <p:sp>
         <p:nvSpPr>
-          <p:cNvPr id="31" name="Text 29"/>
+          <p:cNvPr id="22" name="Text 19"/>
           <p:cNvSpPr/>
           <p:nvPr/>
         </p:nvSpPr>
         <p:spPr>
           <a:xfrm>
-            <a:off x="320040" y="960120"/>
-            <a:ext cx="3429000" cy="1371600"/>
+            <a:off x="274320" y="960120"/>
+            <a:ext cx="3291840" cy="1371600"/>
           </a:xfrm>
           <a:prstGeom prst="rect">
             <a:avLst/>
@@ -1990,13 +1802,13 @@
       </p:sp>
       <p:sp>
         <p:nvSpPr>
-          <p:cNvPr id="32" name="Shape 30"/>
+          <p:cNvPr id="23" name="Shape 20"/>
           <p:cNvSpPr/>
           <p:nvPr/>
         </p:nvSpPr>
         <p:spPr>
           <a:xfrm>
-            <a:off x="3849624" y="1161288"/>
+            <a:off x="3666744" y="1161288"/>
             <a:ext cx="45720" cy="969264"/>
           </a:xfrm>
           <a:prstGeom prst="roundRect">
@@ -2012,7 +1824,7 @@
       </p:sp>
       <p:sp>
         <p:nvSpPr>
-          <p:cNvPr id="33" name="Text 31"/>
+          <p:cNvPr id="24" name="Text 21"/>
           <p:cNvSpPr/>
           <p:nvPr/>
         </p:nvSpPr>

</xml_diff>